<commit_message>
Serve images from R2; stop deploying local image folders
</commit_message>
<xml_diff>
--- a/Megapress_Photography_Offer.pptx
+++ b/Megapress_Photography_Offer.pptx
@@ -4391,281 +4391,6 @@
 </file>
 
 <file path=ppt/slides/slide5.xml><?xml version="1.0" encoding="utf-8"?>
-<p:sld xmlns:a="http://schemas.openxmlformats.org/drawingml/2006/main" xmlns:p="http://schemas.openxmlformats.org/presentationml/2006/main" xmlns:r="http://schemas.openxmlformats.org/officeDocument/2006/relationships">
-  <p:cSld>
-    <p:spTree>
-      <p:nvGrpSpPr>
-        <p:cNvPr id="1" name=""/>
-        <p:cNvGrpSpPr/>
-        <p:nvPr/>
-      </p:nvGrpSpPr>
-      <p:grpSpPr/>
-      <p:sp>
-        <p:nvSpPr>
-          <p:cNvPr id="2" name="Text 0"/>
-          <p:cNvSpPr/>
-          <p:nvPr/>
-        </p:nvSpPr>
-        <p:spPr>
-          <a:xfrm>
-            <a:off x="502920" y="411480"/>
-            <a:ext cx="8229600" cy="274320"/>
-          </a:xfrm>
-          <a:prstGeom prst="rect">
-            <a:avLst/>
-          </a:prstGeom>
-          <a:noFill/>
-          <a:ln/>
-        </p:spPr>
-        <p:txBody>
-          <a:bodyPr wrap="square" lIns="0" tIns="0" rIns="0" bIns="0" rtlCol="0" anchor="ctr"/>
-          <a:lstStyle/>
-          <a:p>
-            <a:pPr marL="0" indent="0">
-              <a:buNone/>
-            </a:pPr>
-            <a:r>
-              <a:rPr lang="en-US" sz="900" b="1" kern="0" spc="400" dirty="0">
-                <a:solidFill>
-                  <a:srgbClr val="7A2800"/>
-                </a:solidFill>
-                <a:latin typeface="Courier New" pitchFamily="34" charset="0"/>
-                <a:ea typeface="Courier New" pitchFamily="34" charset="-122"/>
-                <a:cs typeface="Courier New" pitchFamily="34" charset="-120"/>
-              </a:rPr>
-              <a:t>OWNERSHIP &amp; COPYRIGHT</a:t>
-            </a:r>
-            <a:endParaRPr lang="en-US" sz="900" dirty="0"/>
-          </a:p>
-        </p:txBody>
-      </p:sp>
-      <p:sp>
-        <p:nvSpPr>
-          <p:cNvPr id="3" name="Text 1"/>
-          <p:cNvSpPr/>
-          <p:nvPr/>
-        </p:nvSpPr>
-        <p:spPr>
-          <a:xfrm>
-            <a:off x="502920" y="896112"/>
-            <a:ext cx="6858000" cy="2011680"/>
-          </a:xfrm>
-          <a:prstGeom prst="rect">
-            <a:avLst/>
-          </a:prstGeom>
-          <a:noFill/>
-          <a:ln/>
-        </p:spPr>
-        <p:txBody>
-          <a:bodyPr wrap="square" lIns="0" tIns="0" rIns="0" bIns="0" rtlCol="0" anchor="ctr"/>
-          <a:lstStyle/>
-          <a:p>
-            <a:pPr marL="0" indent="0">
-              <a:lnSpc>
-                <a:spcPct val="105000"/>
-              </a:lnSpc>
-              <a:buNone/>
-            </a:pPr>
-            <a:r>
-              <a:rPr lang="en-US" sz="5200" b="1" dirty="0">
-                <a:solidFill>
-                  <a:srgbClr val="F5F4F0"/>
-                </a:solidFill>
-                <a:latin typeface="Cambria" pitchFamily="34" charset="0"/>
-                <a:ea typeface="Cambria" pitchFamily="34" charset="-122"/>
-                <a:cs typeface="Cambria" pitchFamily="34" charset="-120"/>
-              </a:rPr>
-              <a:t>Own the images</a:t>
-            </a:r>
-            <a:endParaRPr lang="en-US" sz="5200" dirty="0"/>
-          </a:p>
-          <a:p>
-            <a:pPr marL="0" indent="0">
-              <a:lnSpc>
-                <a:spcPct val="105000"/>
-              </a:lnSpc>
-              <a:buNone/>
-            </a:pPr>
-            <a:r>
-              <a:rPr lang="en-US" sz="5200" b="1" dirty="0">
-                <a:solidFill>
-                  <a:srgbClr val="F5F4F0"/>
-                </a:solidFill>
-                <a:latin typeface="Cambria" pitchFamily="34" charset="0"/>
-                <a:ea typeface="Cambria" pitchFamily="34" charset="-122"/>
-                <a:cs typeface="Cambria" pitchFamily="34" charset="-120"/>
-              </a:rPr>
-              <a:t>outright.</a:t>
-            </a:r>
-            <a:endParaRPr lang="en-US" sz="5200" dirty="0"/>
-          </a:p>
-        </p:txBody>
-      </p:sp>
-      <p:sp>
-        <p:nvSpPr>
-          <p:cNvPr id="4" name="Text 2"/>
-          <p:cNvSpPr/>
-          <p:nvPr/>
-        </p:nvSpPr>
-        <p:spPr>
-          <a:xfrm>
-            <a:off x="502920" y="2999232"/>
-            <a:ext cx="5943600" cy="1298448"/>
-          </a:xfrm>
-          <a:prstGeom prst="rect">
-            <a:avLst/>
-          </a:prstGeom>
-          <a:noFill/>
-          <a:ln/>
-        </p:spPr>
-        <p:txBody>
-          <a:bodyPr wrap="square" lIns="0" tIns="0" rIns="0" bIns="0" rtlCol="0" anchor="ctr"/>
-          <a:lstStyle/>
-          <a:p>
-            <a:pPr marL="0" indent="0">
-              <a:lnSpc>
-                <a:spcPct val="150000"/>
-              </a:lnSpc>
-              <a:buNone/>
-            </a:pPr>
-            <a:r>
-              <a:rPr lang="en-US" sz="1300" dirty="0">
-                <a:solidFill>
-                  <a:srgbClr val="FFD0BB"/>
-                </a:solidFill>
-                <a:latin typeface="Calibri" pitchFamily="34" charset="0"/>
-                <a:ea typeface="Calibri" pitchFamily="34" charset="-122"/>
-                <a:cs typeface="Calibri" pitchFamily="34" charset="-120"/>
-              </a:rPr>
-              <a:t>Standard coverage is licensed for your use. If you would rather hold the images yourself, a full copyright buyout is available — you own the full usage and exploitation rights.</a:t>
-            </a:r>
-            <a:endParaRPr lang="en-US" sz="1300" dirty="0"/>
-          </a:p>
-        </p:txBody>
-      </p:sp>
-      <p:sp>
-        <p:nvSpPr>
-          <p:cNvPr id="5" name="Shape 3"/>
-          <p:cNvSpPr/>
-          <p:nvPr/>
-        </p:nvSpPr>
-        <p:spPr>
-          <a:xfrm>
-            <a:off x="7315200" y="822960"/>
-            <a:ext cx="1508760" cy="3291840"/>
-          </a:xfrm>
-          <a:prstGeom prst="rect">
-            <a:avLst/>
-          </a:prstGeom>
-          <a:solidFill>
-            <a:srgbClr val="7A2800"/>
-          </a:solidFill>
-          <a:ln w="12700">
-            <a:solidFill>
-              <a:srgbClr val="7A2800"/>
-            </a:solidFill>
-            <a:prstDash val="solid"/>
-          </a:ln>
-        </p:spPr>
-        <p:txBody>
-          <a:bodyPr/>
-          <a:lstStyle/>
-          <a:p>
-            <a:endParaRPr lang="en-US"/>
-          </a:p>
-        </p:txBody>
-      </p:sp>
-      <p:sp>
-        <p:nvSpPr>
-          <p:cNvPr id="6" name="Text 4"/>
-          <p:cNvSpPr/>
-          <p:nvPr/>
-        </p:nvSpPr>
-        <p:spPr>
-          <a:xfrm>
-            <a:off x="7315200" y="1828800"/>
-            <a:ext cx="1508760" cy="1371600"/>
-          </a:xfrm>
-          <a:prstGeom prst="rect">
-            <a:avLst/>
-          </a:prstGeom>
-          <a:noFill/>
-          <a:ln/>
-        </p:spPr>
-        <p:txBody>
-          <a:bodyPr wrap="square" lIns="0" tIns="0" rIns="0" bIns="0" rtlCol="0" anchor="ctr"/>
-          <a:lstStyle/>
-          <a:p>
-            <a:pPr marL="0" indent="0" algn="ctr">
-              <a:lnSpc>
-                <a:spcPct val="140000"/>
-              </a:lnSpc>
-              <a:buNone/>
-            </a:pPr>
-            <a:r>
-              <a:rPr lang="en-US" sz="1600" b="1" dirty="0">
-                <a:solidFill>
-                  <a:srgbClr val="FF5A1F"/>
-                </a:solidFill>
-                <a:latin typeface="Cambria" pitchFamily="34" charset="0"/>
-                <a:ea typeface="Cambria" pitchFamily="34" charset="-122"/>
-                <a:cs typeface="Cambria" pitchFamily="34" charset="-120"/>
-              </a:rPr>
-              <a:t>FULL</a:t>
-            </a:r>
-            <a:endParaRPr lang="en-US" sz="1600" dirty="0"/>
-          </a:p>
-          <a:p>
-            <a:pPr marL="0" indent="0" algn="ctr">
-              <a:lnSpc>
-                <a:spcPct val="140000"/>
-              </a:lnSpc>
-              <a:buNone/>
-            </a:pPr>
-            <a:r>
-              <a:rPr lang="en-US" sz="1600" b="1" dirty="0">
-                <a:solidFill>
-                  <a:srgbClr val="FF5A1F"/>
-                </a:solidFill>
-                <a:latin typeface="Cambria" pitchFamily="34" charset="0"/>
-                <a:ea typeface="Cambria" pitchFamily="34" charset="-122"/>
-                <a:cs typeface="Cambria" pitchFamily="34" charset="-120"/>
-              </a:rPr>
-              <a:t>COPYRIGHT</a:t>
-            </a:r>
-            <a:endParaRPr lang="en-US" sz="1600" dirty="0"/>
-          </a:p>
-          <a:p>
-            <a:pPr marL="0" indent="0" algn="ctr">
-              <a:lnSpc>
-                <a:spcPct val="140000"/>
-              </a:lnSpc>
-              <a:buNone/>
-            </a:pPr>
-            <a:r>
-              <a:rPr lang="en-US" sz="1600" b="1" dirty="0">
-                <a:solidFill>
-                  <a:srgbClr val="FF5A1F"/>
-                </a:solidFill>
-                <a:latin typeface="Cambria" pitchFamily="34" charset="0"/>
-                <a:ea typeface="Cambria" pitchFamily="34" charset="-122"/>
-                <a:cs typeface="Cambria" pitchFamily="34" charset="-120"/>
-              </a:rPr>
-              <a:t>BUYOUT</a:t>
-            </a:r>
-            <a:endParaRPr lang="en-US" sz="1600" dirty="0"/>
-          </a:p>
-        </p:txBody>
-      </p:sp>
-    </p:spTree>
-  </p:cSld>
-  <p:clrMapOvr>
-    <a:masterClrMapping/>
-  </p:clrMapOvr>
-</p:sld>
-</file>
-
-<file path=ppt/slides/slide6.xml><?xml version="1.0" encoding="utf-8"?>
 <p:sld xmlns:a="http://schemas.openxmlformats.org/drawingml/2006/main" xmlns:r="http://schemas.openxmlformats.org/officeDocument/2006/relationships" xmlns:p="http://schemas.openxmlformats.org/presentationml/2006/main">
   <p:cSld name="Slide 5">
     <p:bg>
@@ -4955,7 +4680,7 @@
 </p:sld>
 </file>
 
-<file path=ppt/slides/slide7.xml><?xml version="1.0" encoding="utf-8"?>
+<file path=ppt/slides/slide6.xml><?xml version="1.0" encoding="utf-8"?>
 <p:sld xmlns:a="http://schemas.openxmlformats.org/drawingml/2006/main" xmlns:r="http://schemas.openxmlformats.org/officeDocument/2006/relationships" xmlns:p="http://schemas.openxmlformats.org/presentationml/2006/main">
   <p:cSld name="Slide 6">
     <p:bg>
@@ -5828,7 +5553,7 @@
 </p:sld>
 </file>
 
-<file path=ppt/slides/slide8.xml><?xml version="1.0" encoding="utf-8"?>
+<file path=ppt/slides/slide7.xml><?xml version="1.0" encoding="utf-8"?>
 <p:sld xmlns:a="http://schemas.openxmlformats.org/drawingml/2006/main" xmlns:r="http://schemas.openxmlformats.org/officeDocument/2006/relationships" xmlns:p="http://schemas.openxmlformats.org/presentationml/2006/main">
   <p:cSld name="Slide 8">
     <p:bg>

</xml_diff>